<commit_message>
Fix deck: remove stray note, correct vLLM-Ascend, drop redundant blocks
</commit_message>
<xml_diff>
--- a/vLLM-Ascend_从一份日志看六大模块层.pptx
+++ b/vLLM-Ascend_从一份日志看六大模块层.pptx
@@ -7789,351 +7789,6 @@
           </a:p>
         </p:txBody>
       </p:sp>
-      <p:sp>
-        <p:nvSpPr>
-          <p:cNvPr id="42" name="TextBox 41"/>
-          <p:cNvSpPr txBox="1"/>
-          <p:nvPr/>
-        </p:nvSpPr>
-        <p:spPr>
-          <a:xfrm>
-            <a:off x="521207" y="4828032"/>
-            <a:ext cx="2194560" cy="201168"/>
-          </a:xfrm>
-          <a:prstGeom prst="rect">
-            <a:avLst/>
-          </a:prstGeom>
-          <a:noFill/>
-        </p:spPr>
-        <p:txBody>
-          <a:bodyPr wrap="square" lIns="0" tIns="0" rIns="0" bIns="0" anchor="t">
-            <a:noAutofit/>
-          </a:bodyPr>
-          <a:lstStyle/>
-          <a:p>
-            <a:pPr algn="l">
-              <a:lnSpc>
-                <a:spcPct val="110000"/>
-              </a:lnSpc>
-              <a:spcBef>
-                <a:spcPts val="0"/>
-              </a:spcBef>
-              <a:spcAft>
-                <a:spcPts val="0"/>
-              </a:spcAft>
-            </a:pPr>
-            <a:r>
-              <a:rPr sz="850" b="1" i="0" spc="180">
-                <a:solidFill>
-                  <a:srgbClr val="C00000"/>
-                </a:solidFill>
-                <a:latin typeface="Consolas"/>
-                <a:ea typeface="Consolas"/>
-                <a:cs typeface="Consolas"/>
-              </a:rPr>
-              <a:t>运 行 时 三 步</a:t>
-            </a:r>
-          </a:p>
-        </p:txBody>
-      </p:sp>
-      <p:sp>
-        <p:nvSpPr>
-          <p:cNvPr id="43" name="Rounded Rectangle 42"/>
-          <p:cNvSpPr/>
-          <p:nvPr/>
-        </p:nvSpPr>
-        <p:spPr>
-          <a:xfrm>
-            <a:off x="502920" y="5047488"/>
-            <a:ext cx="2606040" cy="384048"/>
-          </a:xfrm>
-          <a:prstGeom prst="roundRect">
-            <a:avLst>
-              <a:gd name="adj" fmla="val 10000"/>
-            </a:avLst>
-          </a:prstGeom>
-          <a:solidFill>
-            <a:srgbClr val="F6F7F9"/>
-          </a:solidFill>
-          <a:ln w="10160">
-            <a:solidFill>
-              <a:srgbClr val="DCE1E7"/>
-            </a:solidFill>
-          </a:ln>
-          <a:effectLst/>
-        </p:spPr>
-        <p:style>
-          <a:lnRef idx="1">
-            <a:schemeClr val="accent1"/>
-          </a:lnRef>
-          <a:fillRef idx="3">
-            <a:schemeClr val="accent1"/>
-          </a:fillRef>
-          <a:effectRef idx="2">
-            <a:schemeClr val="accent1"/>
-          </a:effectRef>
-          <a:fontRef idx="minor">
-            <a:schemeClr val="lt1"/>
-          </a:fontRef>
-        </p:style>
-        <p:txBody>
-          <a:bodyPr wrap="square" lIns="18288" tIns="0" rIns="18288" bIns="0" rtlCol="0" anchor="ctr">
-            <a:noAutofit/>
-          </a:bodyPr>
-          <a:lstStyle/>
-          <a:p>
-            <a:pPr algn="ctr">
-              <a:lnSpc>
-                <a:spcPct val="100000"/>
-              </a:lnSpc>
-              <a:spcAft>
-                <a:spcPts val="0"/>
-              </a:spcAft>
-            </a:pPr>
-            <a:r>
-              <a:rPr sz="950" b="1" i="0">
-                <a:solidFill>
-                  <a:srgbClr val="0A5B66"/>
-                </a:solidFill>
-                <a:latin typeface="Consolas"/>
-                <a:ea typeface="Consolas"/>
-                <a:cs typeface="Consolas"/>
-              </a:rPr>
-              <a:t>_prepare_inputs</a:t>
-            </a:r>
-          </a:p>
-        </p:txBody>
-      </p:sp>
-      <p:sp>
-        <p:nvSpPr>
-          <p:cNvPr id="44" name="Rounded Rectangle 43"/>
-          <p:cNvSpPr/>
-          <p:nvPr/>
-        </p:nvSpPr>
-        <p:spPr>
-          <a:xfrm>
-            <a:off x="3310128" y="5047488"/>
-            <a:ext cx="2331720" cy="384048"/>
-          </a:xfrm>
-          <a:prstGeom prst="roundRect">
-            <a:avLst>
-              <a:gd name="adj" fmla="val 10000"/>
-            </a:avLst>
-          </a:prstGeom>
-          <a:solidFill>
-            <a:srgbClr val="F6F7F9"/>
-          </a:solidFill>
-          <a:ln w="10160">
-            <a:solidFill>
-              <a:srgbClr val="DCE1E7"/>
-            </a:solidFill>
-          </a:ln>
-          <a:effectLst/>
-        </p:spPr>
-        <p:style>
-          <a:lnRef idx="1">
-            <a:schemeClr val="accent1"/>
-          </a:lnRef>
-          <a:fillRef idx="3">
-            <a:schemeClr val="accent1"/>
-          </a:fillRef>
-          <a:effectRef idx="2">
-            <a:schemeClr val="accent1"/>
-          </a:effectRef>
-          <a:fontRef idx="minor">
-            <a:schemeClr val="lt1"/>
-          </a:fontRef>
-        </p:style>
-        <p:txBody>
-          <a:bodyPr wrap="square" lIns="18288" tIns="0" rIns="18288" bIns="0" rtlCol="0" anchor="ctr">
-            <a:noAutofit/>
-          </a:bodyPr>
-          <a:lstStyle/>
-          <a:p>
-            <a:pPr algn="ctr">
-              <a:lnSpc>
-                <a:spcPct val="100000"/>
-              </a:lnSpc>
-              <a:spcAft>
-                <a:spcPts val="0"/>
-              </a:spcAft>
-            </a:pPr>
-            <a:r>
-              <a:rPr sz="950" b="1" i="0">
-                <a:solidFill>
-                  <a:srgbClr val="0A5B66"/>
-                </a:solidFill>
-                <a:latin typeface="Consolas"/>
-                <a:ea typeface="Consolas"/>
-                <a:cs typeface="Consolas"/>
-              </a:rPr>
-              <a:t>forward</a:t>
-            </a:r>
-          </a:p>
-        </p:txBody>
-      </p:sp>
-      <p:sp>
-        <p:nvSpPr>
-          <p:cNvPr id="45" name="Rounded Rectangle 44"/>
-          <p:cNvSpPr/>
-          <p:nvPr/>
-        </p:nvSpPr>
-        <p:spPr>
-          <a:xfrm>
-            <a:off x="5870448" y="5047488"/>
-            <a:ext cx="1417320" cy="384048"/>
-          </a:xfrm>
-          <a:prstGeom prst="roundRect">
-            <a:avLst>
-              <a:gd name="adj" fmla="val 10000"/>
-            </a:avLst>
-          </a:prstGeom>
-          <a:solidFill>
-            <a:srgbClr val="F6F7F9"/>
-          </a:solidFill>
-          <a:ln w="10160">
-            <a:solidFill>
-              <a:srgbClr val="DCE1E7"/>
-            </a:solidFill>
-          </a:ln>
-          <a:effectLst/>
-        </p:spPr>
-        <p:style>
-          <a:lnRef idx="1">
-            <a:schemeClr val="accent1"/>
-          </a:lnRef>
-          <a:fillRef idx="3">
-            <a:schemeClr val="accent1"/>
-          </a:fillRef>
-          <a:effectRef idx="2">
-            <a:schemeClr val="accent1"/>
-          </a:effectRef>
-          <a:fontRef idx="minor">
-            <a:schemeClr val="lt1"/>
-          </a:fontRef>
-        </p:style>
-        <p:txBody>
-          <a:bodyPr wrap="square" lIns="18288" tIns="0" rIns="18288" bIns="0" rtlCol="0" anchor="ctr">
-            <a:noAutofit/>
-          </a:bodyPr>
-          <a:lstStyle/>
-          <a:p>
-            <a:pPr algn="ctr">
-              <a:lnSpc>
-                <a:spcPct val="100000"/>
-              </a:lnSpc>
-              <a:spcAft>
-                <a:spcPts val="0"/>
-              </a:spcAft>
-            </a:pPr>
-            <a:r>
-              <a:rPr sz="950" b="1" i="0">
-                <a:solidFill>
-                  <a:srgbClr val="C00000"/>
-                </a:solidFill>
-                <a:latin typeface="微软雅黑"/>
-                <a:ea typeface="微软雅黑"/>
-                <a:cs typeface="微软雅黑"/>
-              </a:rPr>
-              <a:t>采样</a:t>
-            </a:r>
-          </a:p>
-        </p:txBody>
-      </p:sp>
-      <p:sp>
-        <p:nvSpPr>
-          <p:cNvPr id="46" name="TextBox 45"/>
-          <p:cNvSpPr txBox="1"/>
-          <p:nvPr/>
-        </p:nvSpPr>
-        <p:spPr>
-          <a:xfrm>
-            <a:off x="3145536" y="5029200"/>
-            <a:ext cx="146304" cy="219456"/>
-          </a:xfrm>
-          <a:prstGeom prst="rect">
-            <a:avLst/>
-          </a:prstGeom>
-          <a:noFill/>
-        </p:spPr>
-        <p:txBody>
-          <a:bodyPr wrap="square" lIns="0" tIns="0" rIns="0" bIns="0" anchor="t">
-            <a:noAutofit/>
-          </a:bodyPr>
-          <a:lstStyle/>
-          <a:p>
-            <a:pPr algn="l">
-              <a:lnSpc>
-                <a:spcPct val="110000"/>
-              </a:lnSpc>
-              <a:spcBef>
-                <a:spcPts val="0"/>
-              </a:spcBef>
-              <a:spcAft>
-                <a:spcPts val="0"/>
-              </a:spcAft>
-            </a:pPr>
-            <a:r>
-              <a:rPr sz="1300" b="1" i="0">
-                <a:solidFill>
-                  <a:srgbClr val="B9C1CB"/>
-                </a:solidFill>
-                <a:latin typeface="Consolas"/>
-                <a:ea typeface="Consolas"/>
-                <a:cs typeface="Consolas"/>
-              </a:rPr>
-              <a:t>›</a:t>
-            </a:r>
-          </a:p>
-        </p:txBody>
-      </p:sp>
-      <p:sp>
-        <p:nvSpPr>
-          <p:cNvPr id="47" name="TextBox 46"/>
-          <p:cNvSpPr txBox="1"/>
-          <p:nvPr/>
-        </p:nvSpPr>
-        <p:spPr>
-          <a:xfrm>
-            <a:off x="5669280" y="5029200"/>
-            <a:ext cx="146304" cy="219456"/>
-          </a:xfrm>
-          <a:prstGeom prst="rect">
-            <a:avLst/>
-          </a:prstGeom>
-          <a:noFill/>
-        </p:spPr>
-        <p:txBody>
-          <a:bodyPr wrap="square" lIns="0" tIns="0" rIns="0" bIns="0" anchor="t">
-            <a:noAutofit/>
-          </a:bodyPr>
-          <a:lstStyle/>
-          <a:p>
-            <a:pPr algn="l">
-              <a:lnSpc>
-                <a:spcPct val="110000"/>
-              </a:lnSpc>
-              <a:spcBef>
-                <a:spcPts val="0"/>
-              </a:spcBef>
-              <a:spcAft>
-                <a:spcPts val="0"/>
-              </a:spcAft>
-            </a:pPr>
-            <a:r>
-              <a:rPr sz="1300" b="1" i="0">
-                <a:solidFill>
-                  <a:srgbClr val="B9C1CB"/>
-                </a:solidFill>
-                <a:latin typeface="Consolas"/>
-                <a:ea typeface="Consolas"/>
-                <a:cs typeface="Consolas"/>
-              </a:rPr>
-              <a:t>›</a:t>
-            </a:r>
-          </a:p>
-        </p:txBody>
-      </p:sp>
     </p:spTree>
   </p:cSld>
   <p:clrMapOvr>
@@ -12203,53 +11858,6 @@
           </a:p>
         </p:txBody>
       </p:sp>
-      <p:sp>
-        <p:nvSpPr>
-          <p:cNvPr id="28" name="TextBox 27"/>
-          <p:cNvSpPr txBox="1"/>
-          <p:nvPr/>
-        </p:nvSpPr>
-        <p:spPr>
-          <a:xfrm>
-            <a:off x="9372600" y="1956816"/>
-            <a:ext cx="1874519" cy="219456"/>
-          </a:xfrm>
-          <a:prstGeom prst="rect">
-            <a:avLst/>
-          </a:prstGeom>
-          <a:noFill/>
-        </p:spPr>
-        <p:txBody>
-          <a:bodyPr wrap="square" lIns="0" tIns="0" rIns="0" bIns="0" anchor="t">
-            <a:noAutofit/>
-          </a:bodyPr>
-          <a:lstStyle/>
-          <a:p>
-            <a:pPr algn="r">
-              <a:lnSpc>
-                <a:spcPct val="110000"/>
-              </a:lnSpc>
-              <a:spcBef>
-                <a:spcPts val="0"/>
-              </a:spcBef>
-              <a:spcAft>
-                <a:spcPts val="0"/>
-              </a:spcAft>
-            </a:pPr>
-            <a:r>
-              <a:rPr sz="850" b="1" i="0">
-                <a:solidFill>
-                  <a:srgbClr val="C00000"/>
-                </a:solidFill>
-                <a:latin typeface="Consolas"/>
-                <a:ea typeface="Consolas"/>
-                <a:cs typeface="Consolas"/>
-              </a:rPr>
-              <a:t>7 s  ·  0.25 GiB</a:t>
-            </a:r>
-          </a:p>
-        </p:txBody>
-      </p:sp>
       <p:cxnSp>
         <p:nvCxnSpPr>
           <p:cNvPr id="29" name="Connector 28"/>
@@ -21773,7 +21381,7 @@
                 <a:ea typeface="微软雅黑"/>
                 <a:cs typeface="微软雅黑"/>
               </a:rPr>
-              <a:t>vllm</a:t>
+              <a:t>vLLM</a:t>
             </a:r>
             <a:r>
               <a:rPr lang="en-US" altLang="zh-CN" sz="2800" b="1" i="0" dirty="0">
@@ -21784,7 +21392,7 @@
                 <a:ea typeface="微软雅黑"/>
                 <a:cs typeface="微软雅黑"/>
               </a:rPr>
-              <a:t>-ascend</a:t>
+              <a:t>-Ascend</a:t>
             </a:r>
             <a:r>
               <a:rPr lang="zh-CN" altLang="en-US" sz="2800" b="1" i="0" dirty="0">
@@ -28007,7 +27615,7 @@
                 <a:ea typeface="微软雅黑"/>
                 <a:cs typeface="微软雅黑"/>
               </a:rPr>
-              <a:t>插入</a:t>
+              <a:t>挂载</a:t>
             </a:r>
             <a:r>
               <a:rPr sz="1700" b="0" i="0" dirty="0">
@@ -28151,7 +27759,7 @@
                 <a:ea typeface="微软雅黑"/>
                 <a:cs typeface="微软雅黑"/>
               </a:rPr>
-              <a:t>插入</a:t>
+              <a:t>挂载</a:t>
             </a:r>
             <a:endParaRPr sz="1400" b="1" i="0" dirty="0">
               <a:solidFill>
@@ -28810,210 +28418,6 @@
                 <a:cs typeface="微软雅黑"/>
               </a:rPr>
               <a:t>vllm-ascend  ·  插件 + patch 外壳</a:t>
-            </a:r>
-          </a:p>
-        </p:txBody>
-      </p:sp>
-      <p:sp>
-        <p:nvSpPr>
-          <p:cNvPr id="29" name="Rounded Rectangle 28"/>
-          <p:cNvSpPr/>
-          <p:nvPr/>
-        </p:nvSpPr>
-        <p:spPr>
-          <a:xfrm>
-            <a:off x="7498079" y="4389120"/>
-            <a:ext cx="1152144" cy="274320"/>
-          </a:xfrm>
-          <a:prstGeom prst="roundRect">
-            <a:avLst>
-              <a:gd name="adj" fmla="val 50000"/>
-            </a:avLst>
-          </a:prstGeom>
-          <a:solidFill>
-            <a:srgbClr val="FFFFFF"/>
-          </a:solidFill>
-          <a:ln w="11430">
-            <a:solidFill>
-              <a:srgbClr val="0E7C8A"/>
-            </a:solidFill>
-          </a:ln>
-          <a:effectLst/>
-        </p:spPr>
-        <p:style>
-          <a:lnRef idx="1">
-            <a:schemeClr val="accent1"/>
-          </a:lnRef>
-          <a:fillRef idx="3">
-            <a:schemeClr val="accent1"/>
-          </a:fillRef>
-          <a:effectRef idx="2">
-            <a:schemeClr val="accent1"/>
-          </a:effectRef>
-          <a:fontRef idx="minor">
-            <a:schemeClr val="lt1"/>
-          </a:fontRef>
-        </p:style>
-        <p:txBody>
-          <a:bodyPr wrap="square" lIns="54864" tIns="9144" rIns="54864" bIns="9144" rtlCol="0" anchor="ctr">
-            <a:noAutofit/>
-          </a:bodyPr>
-          <a:lstStyle/>
-          <a:p>
-            <a:pPr algn="ctr">
-              <a:lnSpc>
-                <a:spcPct val="100000"/>
-              </a:lnSpc>
-              <a:spcAft>
-                <a:spcPts val="0"/>
-              </a:spcAft>
-            </a:pPr>
-            <a:r>
-              <a:rPr sz="760" b="0" i="0">
-                <a:solidFill>
-                  <a:srgbClr val="0A5B66"/>
-                </a:solidFill>
-                <a:latin typeface="Consolas"/>
-                <a:ea typeface="Consolas"/>
-                <a:cs typeface="Consolas"/>
-              </a:rPr>
-              <a:t>entry points</a:t>
-            </a:r>
-          </a:p>
-        </p:txBody>
-      </p:sp>
-      <p:sp>
-        <p:nvSpPr>
-          <p:cNvPr id="30" name="Rounded Rectangle 29"/>
-          <p:cNvSpPr/>
-          <p:nvPr/>
-        </p:nvSpPr>
-        <p:spPr>
-          <a:xfrm>
-            <a:off x="8732520" y="4389120"/>
-            <a:ext cx="1152144" cy="274320"/>
-          </a:xfrm>
-          <a:prstGeom prst="roundRect">
-            <a:avLst>
-              <a:gd name="adj" fmla="val 50000"/>
-            </a:avLst>
-          </a:prstGeom>
-          <a:solidFill>
-            <a:srgbClr val="FFFFFF"/>
-          </a:solidFill>
-          <a:ln w="11430">
-            <a:solidFill>
-              <a:srgbClr val="0E7C8A"/>
-            </a:solidFill>
-          </a:ln>
-          <a:effectLst/>
-        </p:spPr>
-        <p:style>
-          <a:lnRef idx="1">
-            <a:schemeClr val="accent1"/>
-          </a:lnRef>
-          <a:fillRef idx="3">
-            <a:schemeClr val="accent1"/>
-          </a:fillRef>
-          <a:effectRef idx="2">
-            <a:schemeClr val="accent1"/>
-          </a:effectRef>
-          <a:fontRef idx="minor">
-            <a:schemeClr val="lt1"/>
-          </a:fontRef>
-        </p:style>
-        <p:txBody>
-          <a:bodyPr wrap="square" lIns="54864" tIns="9144" rIns="54864" bIns="9144" rtlCol="0" anchor="ctr">
-            <a:noAutofit/>
-          </a:bodyPr>
-          <a:lstStyle/>
-          <a:p>
-            <a:pPr algn="ctr">
-              <a:lnSpc>
-                <a:spcPct val="100000"/>
-              </a:lnSpc>
-              <a:spcAft>
-                <a:spcPts val="0"/>
-              </a:spcAft>
-            </a:pPr>
-            <a:r>
-              <a:rPr sz="760" b="0" i="0">
-                <a:solidFill>
-                  <a:srgbClr val="0A5B66"/>
-                </a:solidFill>
-                <a:latin typeface="Consolas"/>
-                <a:ea typeface="Consolas"/>
-                <a:cs typeface="Consolas"/>
-              </a:rPr>
-              <a:t>NPUPlatform</a:t>
-            </a:r>
-          </a:p>
-        </p:txBody>
-      </p:sp>
-      <p:sp>
-        <p:nvSpPr>
-          <p:cNvPr id="31" name="Rounded Rectangle 30"/>
-          <p:cNvSpPr/>
-          <p:nvPr/>
-        </p:nvSpPr>
-        <p:spPr>
-          <a:xfrm>
-            <a:off x="9948672" y="4389120"/>
-            <a:ext cx="1152144" cy="274320"/>
-          </a:xfrm>
-          <a:prstGeom prst="roundRect">
-            <a:avLst>
-              <a:gd name="adj" fmla="val 50000"/>
-            </a:avLst>
-          </a:prstGeom>
-          <a:solidFill>
-            <a:srgbClr val="FFFFFF"/>
-          </a:solidFill>
-          <a:ln w="11430">
-            <a:solidFill>
-              <a:srgbClr val="0E7C8A"/>
-            </a:solidFill>
-          </a:ln>
-          <a:effectLst/>
-        </p:spPr>
-        <p:style>
-          <a:lnRef idx="1">
-            <a:schemeClr val="accent1"/>
-          </a:lnRef>
-          <a:fillRef idx="3">
-            <a:schemeClr val="accent1"/>
-          </a:fillRef>
-          <a:effectRef idx="2">
-            <a:schemeClr val="accent1"/>
-          </a:effectRef>
-          <a:fontRef idx="minor">
-            <a:schemeClr val="lt1"/>
-          </a:fontRef>
-        </p:style>
-        <p:txBody>
-          <a:bodyPr wrap="square" lIns="54864" tIns="9144" rIns="54864" bIns="9144" rtlCol="0" anchor="ctr">
-            <a:noAutofit/>
-          </a:bodyPr>
-          <a:lstStyle/>
-          <a:p>
-            <a:pPr algn="ctr">
-              <a:lnSpc>
-                <a:spcPct val="100000"/>
-              </a:lnSpc>
-              <a:spcAft>
-                <a:spcPts val="0"/>
-              </a:spcAft>
-            </a:pPr>
-            <a:r>
-              <a:rPr sz="760" b="0" i="0">
-                <a:solidFill>
-                  <a:srgbClr val="0A5B66"/>
-                </a:solidFill>
-                <a:latin typeface="Consolas"/>
-                <a:ea typeface="Consolas"/>
-                <a:cs typeface="Consolas"/>
-              </a:rPr>
-              <a:t>patch/*.py</a:t>
             </a:r>
           </a:p>
         </p:txBody>
@@ -31551,7 +30955,7 @@
                 <a:ea typeface="微软雅黑"/>
                 <a:cs typeface="微软雅黑"/>
               </a:rPr>
-              <a:t>请求从第 1 层进、第 6 层出，中间四层各司其职。本页只列层，不列模块。</a:t>
+              <a:t>请求从第 1 层进、第 6 层出，中间四层各司其职。</a:t>
             </a:r>
           </a:p>
         </p:txBody>
@@ -33821,7 +33225,7 @@
                 <a:ea typeface="微软雅黑"/>
                 <a:cs typeface="微软雅黑"/>
               </a:rPr>
-              <a:t>层 1 · 平台与前端：它管什么</a:t>
+              <a:t>层 1 · 平台与前端：请求入口与 Ascend 接入</a:t>
             </a:r>
           </a:p>
         </p:txBody>

</xml_diff>

<commit_message>
P6: compress 5 stage cards, move outputs right, add real vllm serve command block
</commit_message>
<xml_diff>
--- a/vLLM-Ascend_从一份日志看六大模块层.pptx
+++ b/vLLM-Ascend_从一份日志看六大模块层.pptx
@@ -33653,8 +33653,8 @@
         </p:nvSpPr>
         <p:spPr>
           <a:xfrm>
-            <a:off x="502920" y="1481328"/>
-            <a:ext cx="2057400" cy="2139696"/>
+            <a:off x="502920" y="1426464"/>
+            <a:ext cx="2057400" cy="1225296"/>
           </a:xfrm>
           <a:prstGeom prst="roundRect">
             <a:avLst>
@@ -33702,7 +33702,7 @@
         </p:nvSpPr>
         <p:spPr>
           <a:xfrm>
-            <a:off x="502920" y="1481328"/>
+            <a:off x="502920" y="1426464"/>
             <a:ext cx="2057400" cy="45720"/>
           </a:xfrm>
           <a:prstGeom prst="rect">
@@ -33747,7 +33747,7 @@
         </p:nvSpPr>
         <p:spPr>
           <a:xfrm>
-            <a:off x="649224" y="1609344"/>
+            <a:off x="649224" y="1536192"/>
             <a:ext cx="548640" cy="219456"/>
           </a:xfrm>
           <a:prstGeom prst="rect">
@@ -33794,8 +33794,8 @@
         </p:nvSpPr>
         <p:spPr>
           <a:xfrm>
-            <a:off x="649224" y="1865376"/>
-            <a:ext cx="1783080" cy="292608"/>
+            <a:off x="649224" y="1755648"/>
+            <a:ext cx="1783080" cy="274320"/>
           </a:xfrm>
           <a:prstGeom prst="rect">
             <a:avLst/>
@@ -33841,8 +33841,8 @@
         </p:nvSpPr>
         <p:spPr>
           <a:xfrm>
-            <a:off x="649224" y="2267712"/>
-            <a:ext cx="1783080" cy="786384"/>
+            <a:off x="649224" y="2048256"/>
+            <a:ext cx="1783080" cy="566928"/>
           </a:xfrm>
           <a:prstGeom prst="rect">
             <a:avLst/>
@@ -33889,7 +33889,7 @@
         </p:nvSpPr>
         <p:spPr>
           <a:xfrm>
-            <a:off x="2560320" y="2432304"/>
+            <a:off x="2560320" y="1920240"/>
             <a:ext cx="182880" cy="237744"/>
           </a:xfrm>
           <a:prstGeom prst="rect">
@@ -33936,8 +33936,8 @@
         </p:nvSpPr>
         <p:spPr>
           <a:xfrm>
-            <a:off x="2779776" y="1481328"/>
-            <a:ext cx="2057400" cy="2139696"/>
+            <a:off x="2779776" y="1426464"/>
+            <a:ext cx="2057400" cy="1225296"/>
           </a:xfrm>
           <a:prstGeom prst="roundRect">
             <a:avLst>
@@ -33985,7 +33985,7 @@
         </p:nvSpPr>
         <p:spPr>
           <a:xfrm>
-            <a:off x="2779776" y="1481328"/>
+            <a:off x="2779776" y="1426464"/>
             <a:ext cx="2057400" cy="45720"/>
           </a:xfrm>
           <a:prstGeom prst="rect">
@@ -34030,7 +34030,7 @@
         </p:nvSpPr>
         <p:spPr>
           <a:xfrm>
-            <a:off x="2926080" y="1609344"/>
+            <a:off x="2926080" y="1536192"/>
             <a:ext cx="548640" cy="219456"/>
           </a:xfrm>
           <a:prstGeom prst="rect">
@@ -34077,8 +34077,8 @@
         </p:nvSpPr>
         <p:spPr>
           <a:xfrm>
-            <a:off x="2926080" y="1865376"/>
-            <a:ext cx="1783080" cy="292608"/>
+            <a:off x="2926080" y="1755648"/>
+            <a:ext cx="1783080" cy="274320"/>
           </a:xfrm>
           <a:prstGeom prst="rect">
             <a:avLst/>
@@ -34124,8 +34124,8 @@
         </p:nvSpPr>
         <p:spPr>
           <a:xfrm>
-            <a:off x="2926080" y="2267712"/>
-            <a:ext cx="1783080" cy="786384"/>
+            <a:off x="2926080" y="2048256"/>
+            <a:ext cx="1783080" cy="566928"/>
           </a:xfrm>
           <a:prstGeom prst="rect">
             <a:avLst/>
@@ -34172,7 +34172,7 @@
         </p:nvSpPr>
         <p:spPr>
           <a:xfrm>
-            <a:off x="4837176" y="2432304"/>
+            <a:off x="4837176" y="1920240"/>
             <a:ext cx="182880" cy="237744"/>
           </a:xfrm>
           <a:prstGeom prst="rect">
@@ -34219,8 +34219,8 @@
         </p:nvSpPr>
         <p:spPr>
           <a:xfrm>
-            <a:off x="5056632" y="1481328"/>
-            <a:ext cx="2057400" cy="2139696"/>
+            <a:off x="5056632" y="1426464"/>
+            <a:ext cx="2057400" cy="1225296"/>
           </a:xfrm>
           <a:prstGeom prst="roundRect">
             <a:avLst>
@@ -34268,7 +34268,7 @@
         </p:nvSpPr>
         <p:spPr>
           <a:xfrm>
-            <a:off x="5056632" y="1481328"/>
+            <a:off x="5056632" y="1426464"/>
             <a:ext cx="2057400" cy="45720"/>
           </a:xfrm>
           <a:prstGeom prst="rect">
@@ -34313,7 +34313,7 @@
         </p:nvSpPr>
         <p:spPr>
           <a:xfrm>
-            <a:off x="5202936" y="1609344"/>
+            <a:off x="5202936" y="1536192"/>
             <a:ext cx="548640" cy="219456"/>
           </a:xfrm>
           <a:prstGeom prst="rect">
@@ -34360,8 +34360,8 @@
         </p:nvSpPr>
         <p:spPr>
           <a:xfrm>
-            <a:off x="5202936" y="1865376"/>
-            <a:ext cx="1783080" cy="292608"/>
+            <a:off x="5202936" y="1755648"/>
+            <a:ext cx="1783080" cy="274320"/>
           </a:xfrm>
           <a:prstGeom prst="rect">
             <a:avLst/>
@@ -34407,8 +34407,8 @@
         </p:nvSpPr>
         <p:spPr>
           <a:xfrm>
-            <a:off x="5202936" y="2267712"/>
-            <a:ext cx="1783080" cy="786384"/>
+            <a:off x="5202936" y="2048256"/>
+            <a:ext cx="1783080" cy="566928"/>
           </a:xfrm>
           <a:prstGeom prst="rect">
             <a:avLst/>
@@ -34455,7 +34455,7 @@
         </p:nvSpPr>
         <p:spPr>
           <a:xfrm>
-            <a:off x="7114032" y="2432304"/>
+            <a:off x="7114032" y="1920240"/>
             <a:ext cx="182880" cy="237744"/>
           </a:xfrm>
           <a:prstGeom prst="rect">
@@ -34502,8 +34502,8 @@
         </p:nvSpPr>
         <p:spPr>
           <a:xfrm>
-            <a:off x="7333488" y="1481328"/>
-            <a:ext cx="2057400" cy="2139696"/>
+            <a:off x="7333488" y="1426464"/>
+            <a:ext cx="2057400" cy="1225296"/>
           </a:xfrm>
           <a:prstGeom prst="roundRect">
             <a:avLst>
@@ -34551,7 +34551,7 @@
         </p:nvSpPr>
         <p:spPr>
           <a:xfrm>
-            <a:off x="7333488" y="1481328"/>
+            <a:off x="7333488" y="1426464"/>
             <a:ext cx="2057400" cy="45720"/>
           </a:xfrm>
           <a:prstGeom prst="rect">
@@ -34596,7 +34596,7 @@
         </p:nvSpPr>
         <p:spPr>
           <a:xfrm>
-            <a:off x="7479792" y="1609344"/>
+            <a:off x="7479792" y="1536192"/>
             <a:ext cx="548640" cy="219456"/>
           </a:xfrm>
           <a:prstGeom prst="rect">
@@ -34643,8 +34643,8 @@
         </p:nvSpPr>
         <p:spPr>
           <a:xfrm>
-            <a:off x="7479792" y="1865376"/>
-            <a:ext cx="1783080" cy="292608"/>
+            <a:off x="7479792" y="1755648"/>
+            <a:ext cx="1783080" cy="274320"/>
           </a:xfrm>
           <a:prstGeom prst="rect">
             <a:avLst/>
@@ -34690,8 +34690,8 @@
         </p:nvSpPr>
         <p:spPr>
           <a:xfrm>
-            <a:off x="7479792" y="2267712"/>
-            <a:ext cx="1783080" cy="786384"/>
+            <a:off x="7479792" y="2048256"/>
+            <a:ext cx="1783080" cy="566928"/>
           </a:xfrm>
           <a:prstGeom prst="rect">
             <a:avLst/>
@@ -34738,7 +34738,7 @@
         </p:nvSpPr>
         <p:spPr>
           <a:xfrm>
-            <a:off x="9390888" y="2432304"/>
+            <a:off x="9390888" y="1920240"/>
             <a:ext cx="182880" cy="237744"/>
           </a:xfrm>
           <a:prstGeom prst="rect">
@@ -34785,8 +34785,8 @@
         </p:nvSpPr>
         <p:spPr>
           <a:xfrm>
-            <a:off x="9610344" y="1481328"/>
-            <a:ext cx="2057400" cy="2139696"/>
+            <a:off x="9610344" y="1426464"/>
+            <a:ext cx="2057400" cy="1225296"/>
           </a:xfrm>
           <a:prstGeom prst="roundRect">
             <a:avLst>
@@ -34834,7 +34834,7 @@
         </p:nvSpPr>
         <p:spPr>
           <a:xfrm>
-            <a:off x="9610344" y="1481328"/>
+            <a:off x="9610344" y="1426464"/>
             <a:ext cx="2057400" cy="45720"/>
           </a:xfrm>
           <a:prstGeom prst="rect">
@@ -34879,7 +34879,7 @@
         </p:nvSpPr>
         <p:spPr>
           <a:xfrm>
-            <a:off x="9756648" y="1609344"/>
+            <a:off x="9756648" y="1536192"/>
             <a:ext cx="548640" cy="219456"/>
           </a:xfrm>
           <a:prstGeom prst="rect">
@@ -34926,8 +34926,8 @@
         </p:nvSpPr>
         <p:spPr>
           <a:xfrm>
-            <a:off x="9756648" y="1865376"/>
-            <a:ext cx="1783080" cy="292608"/>
+            <a:off x="9756648" y="1755648"/>
+            <a:ext cx="1783080" cy="274320"/>
           </a:xfrm>
           <a:prstGeom prst="rect">
             <a:avLst/>
@@ -34973,8 +34973,8 @@
         </p:nvSpPr>
         <p:spPr>
           <a:xfrm>
-            <a:off x="9756648" y="2267712"/>
-            <a:ext cx="1783080" cy="786384"/>
+            <a:off x="9756648" y="2048256"/>
+            <a:ext cx="1783080" cy="566928"/>
           </a:xfrm>
           <a:prstGeom prst="rect">
             <a:avLst/>
@@ -35021,8 +35021,8 @@
         </p:nvSpPr>
         <p:spPr>
           <a:xfrm>
-            <a:off x="521207" y="3858768"/>
-            <a:ext cx="1097280" cy="219456"/>
+            <a:off x="7790688" y="2670048"/>
+            <a:ext cx="1097280" cy="201168"/>
           </a:xfrm>
           <a:prstGeom prst="rect">
             <a:avLst/>
@@ -35068,8 +35068,8 @@
         </p:nvSpPr>
         <p:spPr>
           <a:xfrm>
-            <a:off x="502920" y="4297680"/>
-            <a:ext cx="4892040" cy="786384"/>
+            <a:off x="7790688" y="2944368"/>
+            <a:ext cx="3895344" cy="1005840"/>
           </a:xfrm>
           <a:prstGeom prst="roundRect">
             <a:avLst>
@@ -35117,8 +35117,8 @@
         </p:nvSpPr>
         <p:spPr>
           <a:xfrm>
-            <a:off x="731520" y="4389120"/>
-            <a:ext cx="4480560" cy="274320"/>
+            <a:off x="7973567" y="3054096"/>
+            <a:ext cx="3529584" cy="256032"/>
           </a:xfrm>
           <a:prstGeom prst="rect">
             <a:avLst/>
@@ -35175,8 +35175,8 @@
         </p:nvSpPr>
         <p:spPr>
           <a:xfrm>
-            <a:off x="731520" y="4700016"/>
-            <a:ext cx="4480560" cy="219456"/>
+            <a:off x="7973567" y="3328416"/>
+            <a:ext cx="3529584" cy="475488"/>
           </a:xfrm>
           <a:prstGeom prst="rect">
             <a:avLst/>
@@ -35216,59 +35216,14 @@
       </p:sp>
       <p:sp>
         <p:nvSpPr>
-          <p:cNvPr id="46" name="Right Arrow 45"/>
-          <p:cNvSpPr/>
-          <p:nvPr/>
-        </p:nvSpPr>
-        <p:spPr>
-          <a:xfrm>
-            <a:off x="5577840" y="4581144"/>
-            <a:ext cx="566928" cy="219456"/>
-          </a:xfrm>
-          <a:prstGeom prst="rightArrow">
-            <a:avLst/>
-          </a:prstGeom>
-          <a:solidFill>
-            <a:srgbClr val="C00000"/>
-          </a:solidFill>
-          <a:ln>
-            <a:noFill/>
-          </a:ln>
-          <a:effectLst/>
-        </p:spPr>
-        <p:style>
-          <a:lnRef idx="1">
-            <a:schemeClr val="accent1"/>
-          </a:lnRef>
-          <a:fillRef idx="3">
-            <a:schemeClr val="accent1"/>
-          </a:fillRef>
-          <a:effectRef idx="2">
-            <a:schemeClr val="accent1"/>
-          </a:effectRef>
-          <a:fontRef idx="minor">
-            <a:schemeClr val="lt1"/>
-          </a:fontRef>
-        </p:style>
-        <p:txBody>
-          <a:bodyPr rtlCol="0" anchor="ctr"/>
-          <a:lstStyle/>
-          <a:p>
-            <a:pPr algn="ctr"/>
-            <a:endParaRPr/>
-          </a:p>
-        </p:txBody>
-      </p:sp>
-      <p:sp>
-        <p:nvSpPr>
           <p:cNvPr id="47" name="Rounded Rectangle 46"/>
           <p:cNvSpPr/>
           <p:nvPr/>
         </p:nvSpPr>
         <p:spPr>
           <a:xfrm>
-            <a:off x="6327648" y="4297680"/>
-            <a:ext cx="5358384" cy="786384"/>
+            <a:off x="7790688" y="4041648"/>
+            <a:ext cx="3895344" cy="1005840"/>
           </a:xfrm>
           <a:prstGeom prst="roundRect">
             <a:avLst>
@@ -35314,8 +35269,8 @@
         </p:nvSpPr>
         <p:spPr>
           <a:xfrm>
-            <a:off x="6537960" y="4389120"/>
-            <a:ext cx="4937760" cy="274320"/>
+            <a:off x="7973567" y="4151376"/>
+            <a:ext cx="3529584" cy="256032"/>
           </a:xfrm>
           <a:prstGeom prst="rect">
             <a:avLst/>
@@ -35372,8 +35327,8 @@
         </p:nvSpPr>
         <p:spPr>
           <a:xfrm>
-            <a:off x="6537960" y="4700016"/>
-            <a:ext cx="4937760" cy="219456"/>
+            <a:off x="7973567" y="4425696"/>
+            <a:ext cx="3529584" cy="475488"/>
           </a:xfrm>
           <a:prstGeom prst="rect">
             <a:avLst/>
@@ -35407,6 +35362,546 @@
                 <a:cs typeface="微软雅黑"/>
               </a:rPr>
               <a:t>对外提供 HTTP，8 个 API server 进程各持一份路由表</a:t>
+            </a:r>
+          </a:p>
+        </p:txBody>
+      </p:sp>
+      <p:sp>
+        <p:nvSpPr>
+          <p:cNvPr id="50" name="Rectangle 49"/>
+          <p:cNvSpPr/>
+          <p:nvPr/>
+        </p:nvSpPr>
+        <p:spPr>
+          <a:xfrm>
+            <a:off x="502920" y="2944368"/>
+            <a:ext cx="7059168" cy="2103120"/>
+          </a:xfrm>
+          <a:prstGeom prst="rect">
+            <a:avLst/>
+          </a:prstGeom>
+          <a:solidFill>
+            <a:srgbClr val="0B1320"/>
+          </a:solidFill>
+          <a:ln>
+            <a:noFill/>
+          </a:ln>
+          <a:effectLst/>
+        </p:spPr>
+        <p:style>
+          <a:lnRef idx="1">
+            <a:schemeClr val="accent1"/>
+          </a:lnRef>
+          <a:fillRef idx="3">
+            <a:schemeClr val="accent1"/>
+          </a:fillRef>
+          <a:effectRef idx="2">
+            <a:schemeClr val="accent1"/>
+          </a:effectRef>
+          <a:fontRef idx="minor">
+            <a:schemeClr val="lt1"/>
+          </a:fontRef>
+        </p:style>
+        <p:txBody>
+          <a:bodyPr rtlCol="0" anchor="ctr"/>
+          <a:lstStyle/>
+          <a:p>
+            <a:pPr algn="ctr"/>
+          </a:p>
+        </p:txBody>
+      </p:sp>
+      <p:sp>
+        <p:nvSpPr>
+          <p:cNvPr id="51" name="Rectangle 50"/>
+          <p:cNvSpPr/>
+          <p:nvPr/>
+        </p:nvSpPr>
+        <p:spPr>
+          <a:xfrm>
+            <a:off x="502920" y="2944368"/>
+            <a:ext cx="7059168" cy="274320"/>
+          </a:xfrm>
+          <a:prstGeom prst="rect">
+            <a:avLst/>
+          </a:prstGeom>
+          <a:solidFill>
+            <a:srgbClr val="111B2B"/>
+          </a:solidFill>
+          <a:ln>
+            <a:noFill/>
+          </a:ln>
+          <a:effectLst/>
+        </p:spPr>
+        <p:style>
+          <a:lnRef idx="1">
+            <a:schemeClr val="accent1"/>
+          </a:lnRef>
+          <a:fillRef idx="3">
+            <a:schemeClr val="accent1"/>
+          </a:fillRef>
+          <a:effectRef idx="2">
+            <a:schemeClr val="accent1"/>
+          </a:effectRef>
+          <a:fontRef idx="minor">
+            <a:schemeClr val="lt1"/>
+          </a:fontRef>
+        </p:style>
+        <p:txBody>
+          <a:bodyPr rtlCol="0" anchor="ctr"/>
+          <a:lstStyle/>
+          <a:p>
+            <a:pPr algn="ctr"/>
+          </a:p>
+        </p:txBody>
+      </p:sp>
+      <p:sp>
+        <p:nvSpPr>
+          <p:cNvPr id="52" name="Oval 51"/>
+          <p:cNvSpPr/>
+          <p:nvPr/>
+        </p:nvSpPr>
+        <p:spPr>
+          <a:xfrm>
+            <a:off x="649224" y="3040380"/>
+            <a:ext cx="82296" cy="82296"/>
+          </a:xfrm>
+          <a:prstGeom prst="ellipse">
+            <a:avLst/>
+          </a:prstGeom>
+          <a:solidFill>
+            <a:srgbClr val="FF5F57"/>
+          </a:solidFill>
+          <a:ln>
+            <a:noFill/>
+          </a:ln>
+          <a:effectLst/>
+        </p:spPr>
+        <p:style>
+          <a:lnRef idx="1">
+            <a:schemeClr val="accent1"/>
+          </a:lnRef>
+          <a:fillRef idx="3">
+            <a:schemeClr val="accent1"/>
+          </a:fillRef>
+          <a:effectRef idx="2">
+            <a:schemeClr val="accent1"/>
+          </a:effectRef>
+          <a:fontRef idx="minor">
+            <a:schemeClr val="lt1"/>
+          </a:fontRef>
+        </p:style>
+        <p:txBody>
+          <a:bodyPr rtlCol="0" anchor="ctr"/>
+          <a:lstStyle/>
+          <a:p>
+            <a:pPr algn="ctr"/>
+          </a:p>
+        </p:txBody>
+      </p:sp>
+      <p:sp>
+        <p:nvSpPr>
+          <p:cNvPr id="53" name="Oval 52"/>
+          <p:cNvSpPr/>
+          <p:nvPr/>
+        </p:nvSpPr>
+        <p:spPr>
+          <a:xfrm>
+            <a:off x="804672" y="3040380"/>
+            <a:ext cx="82296" cy="82296"/>
+          </a:xfrm>
+          <a:prstGeom prst="ellipse">
+            <a:avLst/>
+          </a:prstGeom>
+          <a:solidFill>
+            <a:srgbClr val="FEBC2E"/>
+          </a:solidFill>
+          <a:ln>
+            <a:noFill/>
+          </a:ln>
+          <a:effectLst/>
+        </p:spPr>
+        <p:style>
+          <a:lnRef idx="1">
+            <a:schemeClr val="accent1"/>
+          </a:lnRef>
+          <a:fillRef idx="3">
+            <a:schemeClr val="accent1"/>
+          </a:fillRef>
+          <a:effectRef idx="2">
+            <a:schemeClr val="accent1"/>
+          </a:effectRef>
+          <a:fontRef idx="minor">
+            <a:schemeClr val="lt1"/>
+          </a:fontRef>
+        </p:style>
+        <p:txBody>
+          <a:bodyPr rtlCol="0" anchor="ctr"/>
+          <a:lstStyle/>
+          <a:p>
+            <a:pPr algn="ctr"/>
+          </a:p>
+        </p:txBody>
+      </p:sp>
+      <p:sp>
+        <p:nvSpPr>
+          <p:cNvPr id="54" name="Oval 53"/>
+          <p:cNvSpPr/>
+          <p:nvPr/>
+        </p:nvSpPr>
+        <p:spPr>
+          <a:xfrm>
+            <a:off x="960120" y="3040380"/>
+            <a:ext cx="82296" cy="82296"/>
+          </a:xfrm>
+          <a:prstGeom prst="ellipse">
+            <a:avLst/>
+          </a:prstGeom>
+          <a:solidFill>
+            <a:srgbClr val="28C840"/>
+          </a:solidFill>
+          <a:ln>
+            <a:noFill/>
+          </a:ln>
+          <a:effectLst/>
+        </p:spPr>
+        <p:style>
+          <a:lnRef idx="1">
+            <a:schemeClr val="accent1"/>
+          </a:lnRef>
+          <a:fillRef idx="3">
+            <a:schemeClr val="accent1"/>
+          </a:fillRef>
+          <a:effectRef idx="2">
+            <a:schemeClr val="accent1"/>
+          </a:effectRef>
+          <a:fontRef idx="minor">
+            <a:schemeClr val="lt1"/>
+          </a:fontRef>
+        </p:style>
+        <p:txBody>
+          <a:bodyPr rtlCol="0" anchor="ctr"/>
+          <a:lstStyle/>
+          <a:p>
+            <a:pPr algn="ctr"/>
+          </a:p>
+        </p:txBody>
+      </p:sp>
+      <p:sp>
+        <p:nvSpPr>
+          <p:cNvPr id="55" name="TextBox 54"/>
+          <p:cNvSpPr txBox="1"/>
+          <p:nvPr/>
+        </p:nvSpPr>
+        <p:spPr>
+          <a:xfrm>
+            <a:off x="1188720" y="2994660"/>
+            <a:ext cx="6035040" cy="182880"/>
+          </a:xfrm>
+          <a:prstGeom prst="rect">
+            <a:avLst/>
+          </a:prstGeom>
+          <a:noFill/>
+        </p:spPr>
+        <p:txBody>
+          <a:bodyPr wrap="none" lIns="0" rIns="0" tIns="0" bIns="0">
+            <a:spAutoFit/>
+          </a:bodyPr>
+          <a:lstStyle/>
+          <a:p>
+            <a:r>
+              <a:rPr sz="800">
+                <a:solidFill>
+                  <a:srgbClr val="7E8DA5"/>
+                </a:solidFill>
+                <a:latin typeface="Consolas"/>
+              </a:rPr>
+              <a:t>vllm serve  ·  CLI 参数入口</a:t>
+            </a:r>
+          </a:p>
+        </p:txBody>
+      </p:sp>
+      <p:sp>
+        <p:nvSpPr>
+          <p:cNvPr id="56" name="TextBox 55"/>
+          <p:cNvSpPr txBox="1"/>
+          <p:nvPr/>
+        </p:nvSpPr>
+        <p:spPr>
+          <a:xfrm>
+            <a:off x="685800" y="3364992"/>
+            <a:ext cx="6729983" cy="1554480"/>
+          </a:xfrm>
+          <a:prstGeom prst="rect">
+            <a:avLst/>
+          </a:prstGeom>
+          <a:noFill/>
+        </p:spPr>
+        <p:txBody>
+          <a:bodyPr wrap="none" lIns="0" rIns="0" tIns="0" bIns="0">
+            <a:spAutoFit/>
+          </a:bodyPr>
+          <a:lstStyle/>
+          <a:p>
+            <a:pPr>
+              <a:lnSpc>
+                <a:spcPct val="108000"/>
+              </a:lnSpc>
+            </a:pPr>
+            <a:r>
+              <a:rPr sz="1100">
+                <a:solidFill>
+                  <a:srgbClr val="45C46A"/>
+                </a:solidFill>
+                <a:latin typeface="Consolas"/>
+              </a:rPr>
+              <a:t>$ </a:t>
+            </a:r>
+            <a:r>
+              <a:rPr sz="1100" b="1">
+                <a:solidFill>
+                  <a:srgbClr val="FFFFFF"/>
+                </a:solidFill>
+                <a:latin typeface="Consolas"/>
+              </a:rPr>
+              <a:t>vllm serve</a:t>
+            </a:r>
+            <a:r>
+              <a:rPr sz="1100">
+                <a:solidFill>
+                  <a:srgbClr val="5AD1E6"/>
+                </a:solidFill>
+                <a:latin typeface="Consolas"/>
+              </a:rPr>
+              <a:t> /mnt/share/.../GLM-5.3-Flash-W8A8-MXFP8-0918 </a:t>
+            </a:r>
+            <a:r>
+              <a:rPr sz="1100">
+                <a:solidFill>
+                  <a:srgbClr val="7E8DA5"/>
+                </a:solidFill>
+                <a:latin typeface="Consolas"/>
+              </a:rPr>
+              <a:t>\</a:t>
+            </a:r>
+          </a:p>
+          <a:p>
+            <a:pPr>
+              <a:lnSpc>
+                <a:spcPct val="108000"/>
+              </a:lnSpc>
+            </a:pPr>
+            <a:r>
+              <a:rPr sz="1100">
+                <a:solidFill>
+                  <a:srgbClr val="A9C7E8"/>
+                </a:solidFill>
+                <a:latin typeface="Consolas"/>
+              </a:rPr>
+              <a:t>    --data-parallel-size </a:t>
+            </a:r>
+            <a:r>
+              <a:rPr sz="1100">
+                <a:solidFill>
+                  <a:srgbClr val="FEBE2E"/>
+                </a:solidFill>
+                <a:latin typeface="Consolas"/>
+              </a:rPr>
+              <a:t>8</a:t>
+            </a:r>
+            <a:r>
+              <a:rPr sz="1100">
+                <a:solidFill>
+                  <a:srgbClr val="7E8DA5"/>
+                </a:solidFill>
+                <a:latin typeface="Consolas"/>
+              </a:rPr>
+              <a:t> \</a:t>
+            </a:r>
+          </a:p>
+          <a:p>
+            <a:pPr>
+              <a:lnSpc>
+                <a:spcPct val="108000"/>
+              </a:lnSpc>
+            </a:pPr>
+            <a:r>
+              <a:rPr sz="1100">
+                <a:solidFill>
+                  <a:srgbClr val="A9C7E8"/>
+                </a:solidFill>
+                <a:latin typeface="Consolas"/>
+              </a:rPr>
+              <a:t>    --enable-expert-parallel</a:t>
+            </a:r>
+            <a:r>
+              <a:rPr sz="1100">
+                <a:solidFill>
+                  <a:srgbClr val="7E8DA5"/>
+                </a:solidFill>
+                <a:latin typeface="Consolas"/>
+              </a:rPr>
+              <a:t> \</a:t>
+            </a:r>
+          </a:p>
+          <a:p>
+            <a:pPr>
+              <a:lnSpc>
+                <a:spcPct val="108000"/>
+              </a:lnSpc>
+            </a:pPr>
+            <a:r>
+              <a:rPr sz="1100">
+                <a:solidFill>
+                  <a:srgbClr val="A9C7E8"/>
+                </a:solidFill>
+                <a:latin typeface="Consolas"/>
+              </a:rPr>
+              <a:t>    --max-model-len </a:t>
+            </a:r>
+            <a:r>
+              <a:rPr sz="1100">
+                <a:solidFill>
+                  <a:srgbClr val="FEBE2E"/>
+                </a:solidFill>
+                <a:latin typeface="Consolas"/>
+              </a:rPr>
+              <a:t>133120</a:t>
+            </a:r>
+            <a:r>
+              <a:rPr sz="1100">
+                <a:solidFill>
+                  <a:srgbClr val="7E8DA5"/>
+                </a:solidFill>
+                <a:latin typeface="Consolas"/>
+              </a:rPr>
+              <a:t> \</a:t>
+            </a:r>
+          </a:p>
+          <a:p>
+            <a:pPr>
+              <a:lnSpc>
+                <a:spcPct val="108000"/>
+              </a:lnSpc>
+            </a:pPr>
+            <a:r>
+              <a:rPr sz="1100">
+                <a:solidFill>
+                  <a:srgbClr val="A9C7E8"/>
+                </a:solidFill>
+                <a:latin typeface="Consolas"/>
+              </a:rPr>
+              <a:t>    --quantization </a:t>
+            </a:r>
+            <a:r>
+              <a:rPr sz="1100">
+                <a:solidFill>
+                  <a:srgbClr val="FEBE2E"/>
+                </a:solidFill>
+                <a:latin typeface="Consolas"/>
+              </a:rPr>
+              <a:t>ascend</a:t>
+            </a:r>
+            <a:r>
+              <a:rPr sz="1100">
+                <a:solidFill>
+                  <a:srgbClr val="7E8DA5"/>
+                </a:solidFill>
+                <a:latin typeface="Consolas"/>
+              </a:rPr>
+              <a:t> \</a:t>
+            </a:r>
+          </a:p>
+          <a:p>
+            <a:pPr>
+              <a:lnSpc>
+                <a:spcPct val="108000"/>
+              </a:lnSpc>
+            </a:pPr>
+            <a:r>
+              <a:rPr sz="1100">
+                <a:solidFill>
+                  <a:srgbClr val="A9C7E8"/>
+                </a:solidFill>
+                <a:latin typeface="Consolas"/>
+              </a:rPr>
+              <a:t>    --speculative-config </a:t>
+            </a:r>
+            <a:r>
+              <a:rPr sz="1100">
+                <a:solidFill>
+                  <a:srgbClr val="FEBE2E"/>
+                </a:solidFill>
+                <a:latin typeface="Consolas"/>
+              </a:rPr>
+              <a:t>'{"method":"mtp","num_speculative_tokens":5}'</a:t>
+            </a:r>
+            <a:r>
+              <a:rPr sz="1100">
+                <a:solidFill>
+                  <a:srgbClr val="7E8DA5"/>
+                </a:solidFill>
+                <a:latin typeface="Consolas"/>
+              </a:rPr>
+              <a:t> \</a:t>
+            </a:r>
+          </a:p>
+          <a:p>
+            <a:pPr>
+              <a:lnSpc>
+                <a:spcPct val="108000"/>
+              </a:lnSpc>
+            </a:pPr>
+            <a:r>
+              <a:rPr sz="1100">
+                <a:solidFill>
+                  <a:srgbClr val="A9C7E8"/>
+                </a:solidFill>
+                <a:latin typeface="Consolas"/>
+              </a:rPr>
+              <a:t>    --port </a:t>
+            </a:r>
+            <a:r>
+              <a:rPr sz="1100">
+                <a:solidFill>
+                  <a:srgbClr val="FEBE2E"/>
+                </a:solidFill>
+                <a:latin typeface="Consolas"/>
+              </a:rPr>
+              <a:t>8017</a:t>
+            </a:r>
+          </a:p>
+        </p:txBody>
+      </p:sp>
+      <p:sp>
+        <p:nvSpPr>
+          <p:cNvPr id="57" name="TextBox 56"/>
+          <p:cNvSpPr txBox="1"/>
+          <p:nvPr/>
+        </p:nvSpPr>
+        <p:spPr>
+          <a:xfrm>
+            <a:off x="685800" y="4535424"/>
+            <a:ext cx="6729983" cy="182880"/>
+          </a:xfrm>
+          <a:prstGeom prst="rect">
+            <a:avLst/>
+          </a:prstGeom>
+          <a:noFill/>
+        </p:spPr>
+        <p:txBody>
+          <a:bodyPr wrap="none" lIns="0" rIns="0" tIns="0" bIns="0">
+            <a:spAutoFit/>
+          </a:bodyPr>
+          <a:lstStyle/>
+          <a:p>
+            <a:r>
+              <a:rPr sz="750">
+                <a:solidFill>
+                  <a:srgbClr val="7E8DA5"/>
+                </a:solidFill>
+                <a:latin typeface="微软雅黑"/>
+              </a:rPr>
+              <a:t>注：命令按该次运行的 non-default args 还原</a:t>
             </a:r>
           </a:p>
         </p:txBody>

</xml_diff>

<commit_message>
P16: replace unclear converging-lines figure with mechanisms->adapter->vllm flow
</commit_message>
<xml_diff>
--- a/vLLM-Ascend_从一份日志看六大模块层.pptx
+++ b/vLLM-Ascend_从一份日志看六大模块层.pptx
@@ -20602,513 +20602,67 @@
                 <a:ea typeface="Consolas"/>
                 <a:cs typeface="Consolas"/>
               </a:rPr>
-              <a:t>SIX  LAYERS  →  ONE  ADAPTER</a:t>
-            </a:r>
-          </a:p>
-        </p:txBody>
-      </p:sp>
-      <p:sp>
-        <p:nvSpPr>
-          <p:cNvPr id="24" name="TextBox 23"/>
-          <p:cNvSpPr txBox="1"/>
-          <p:nvPr/>
-        </p:nvSpPr>
-        <p:spPr>
-          <a:xfrm>
-            <a:off x="6565392" y="2377440"/>
-            <a:ext cx="329184" cy="201168"/>
-          </a:xfrm>
-          <a:prstGeom prst="rect">
-            <a:avLst/>
-          </a:prstGeom>
-          <a:noFill/>
-        </p:spPr>
-        <p:txBody>
-          <a:bodyPr wrap="square" lIns="0" tIns="0" rIns="0" bIns="0" anchor="t">
-            <a:noAutofit/>
-          </a:bodyPr>
-          <a:lstStyle/>
-          <a:p>
-            <a:pPr algn="l">
-              <a:lnSpc>
-                <a:spcPct val="110000"/>
-              </a:lnSpc>
-              <a:spcBef>
-                <a:spcPts val="0"/>
-              </a:spcBef>
-              <a:spcAft>
-                <a:spcPts val="0"/>
-              </a:spcAft>
-            </a:pPr>
-            <a:r>
-              <a:rPr sz="750" b="1" i="0">
-                <a:solidFill>
-                  <a:srgbClr val="8A94A3"/>
-                </a:solidFill>
-                <a:latin typeface="Consolas"/>
-                <a:ea typeface="Consolas"/>
-                <a:cs typeface="Consolas"/>
-              </a:rPr>
-              <a:t>1</a:t>
-            </a:r>
-          </a:p>
-        </p:txBody>
-      </p:sp>
-      <p:cxnSp>
-        <p:nvCxnSpPr>
-          <p:cNvPr id="25" name="Connector 24"/>
-          <p:cNvCxnSpPr/>
-          <p:nvPr/>
-        </p:nvCxnSpPr>
-        <p:spPr>
-          <a:xfrm>
-            <a:off x="6903720" y="2468880"/>
-            <a:ext cx="4087368" cy="2029968"/>
-          </a:xfrm>
-          <a:prstGeom prst="line">
-            <a:avLst/>
-          </a:prstGeom>
-          <a:ln w="11430">
+              <a:t>TWO  MECHANISMS  →  ONE  ADAPTER</a:t>
+            </a:r>
+          </a:p>
+        </p:txBody>
+      </p:sp>
+      <p:sp>
+        <p:nvSpPr>
+          <p:cNvPr id="24" name="Rectangle 23"/>
+          <p:cNvSpPr/>
+          <p:nvPr/>
+        </p:nvSpPr>
+        <p:spPr>
+          <a:xfrm>
+            <a:off x="8321040" y="2907792"/>
+            <a:ext cx="3364992" cy="1188720"/>
+          </a:xfrm>
+          <a:prstGeom prst="rect">
+            <a:avLst/>
+          </a:prstGeom>
+          <a:solidFill>
+            <a:srgbClr val="F6F7F9"/>
+          </a:solidFill>
+          <a:ln w="12700">
             <a:solidFill>
-              <a:srgbClr val="D8C2C2"/>
+              <a:srgbClr val="DCE1E7"/>
             </a:solidFill>
           </a:ln>
+          <a:effectLst/>
         </p:spPr>
         <p:style>
-          <a:lnRef idx="2">
+          <a:lnRef idx="1">
             <a:schemeClr val="accent1"/>
           </a:lnRef>
-          <a:fillRef idx="0">
+          <a:fillRef idx="3">
             <a:schemeClr val="accent1"/>
           </a:fillRef>
-          <a:effectRef idx="1">
+          <a:effectRef idx="2">
             <a:schemeClr val="accent1"/>
           </a:effectRef>
           <a:fontRef idx="minor">
-            <a:schemeClr val="tx1"/>
+            <a:schemeClr val="lt1"/>
           </a:fontRef>
         </p:style>
-      </p:cxnSp>
-      <p:sp>
-        <p:nvSpPr>
-          <p:cNvPr id="26" name="TextBox 25"/>
-          <p:cNvSpPr txBox="1"/>
-          <p:nvPr/>
-        </p:nvSpPr>
-        <p:spPr>
-          <a:xfrm>
-            <a:off x="6565392" y="2706624"/>
-            <a:ext cx="329184" cy="201168"/>
-          </a:xfrm>
-          <a:prstGeom prst="rect">
-            <a:avLst/>
-          </a:prstGeom>
-          <a:noFill/>
-        </p:spPr>
-        <p:txBody>
-          <a:bodyPr wrap="square" lIns="0" tIns="0" rIns="0" bIns="0" anchor="t">
-            <a:noAutofit/>
-          </a:bodyPr>
-          <a:lstStyle/>
-          <a:p>
-            <a:pPr algn="l">
-              <a:lnSpc>
-                <a:spcPct val="110000"/>
-              </a:lnSpc>
-              <a:spcBef>
-                <a:spcPts val="0"/>
-              </a:spcBef>
-              <a:spcAft>
-                <a:spcPts val="0"/>
-              </a:spcAft>
-            </a:pPr>
-            <a:r>
-              <a:rPr sz="750" b="1" i="0">
-                <a:solidFill>
-                  <a:srgbClr val="8A94A3"/>
-                </a:solidFill>
-                <a:latin typeface="Consolas"/>
-                <a:ea typeface="Consolas"/>
-                <a:cs typeface="Consolas"/>
-              </a:rPr>
-              <a:t>2</a:t>
-            </a:r>
-          </a:p>
-        </p:txBody>
-      </p:sp>
-      <p:cxnSp>
-        <p:nvCxnSpPr>
-          <p:cNvPr id="27" name="Connector 26"/>
-          <p:cNvCxnSpPr/>
-          <p:nvPr/>
-        </p:nvCxnSpPr>
-        <p:spPr>
-          <a:xfrm>
-            <a:off x="6903720" y="2798064"/>
-            <a:ext cx="4087368" cy="1700784"/>
-          </a:xfrm>
-          <a:prstGeom prst="line">
-            <a:avLst/>
-          </a:prstGeom>
-          <a:ln w="11430">
-            <a:solidFill>
-              <a:srgbClr val="D8C2C2"/>
-            </a:solidFill>
-          </a:ln>
-        </p:spPr>
-        <p:style>
-          <a:lnRef idx="2">
-            <a:schemeClr val="accent1"/>
-          </a:lnRef>
-          <a:fillRef idx="0">
-            <a:schemeClr val="accent1"/>
-          </a:fillRef>
-          <a:effectRef idx="1">
-            <a:schemeClr val="accent1"/>
-          </a:effectRef>
-          <a:fontRef idx="minor">
-            <a:schemeClr val="tx1"/>
-          </a:fontRef>
-        </p:style>
-      </p:cxnSp>
-      <p:sp>
-        <p:nvSpPr>
-          <p:cNvPr id="28" name="TextBox 27"/>
-          <p:cNvSpPr txBox="1"/>
-          <p:nvPr/>
-        </p:nvSpPr>
-        <p:spPr>
-          <a:xfrm>
-            <a:off x="6565392" y="3035808"/>
-            <a:ext cx="329184" cy="201168"/>
-          </a:xfrm>
-          <a:prstGeom prst="rect">
-            <a:avLst/>
-          </a:prstGeom>
-          <a:noFill/>
-        </p:spPr>
-        <p:txBody>
-          <a:bodyPr wrap="square" lIns="0" tIns="0" rIns="0" bIns="0" anchor="t">
-            <a:noAutofit/>
-          </a:bodyPr>
-          <a:lstStyle/>
-          <a:p>
-            <a:pPr algn="l">
-              <a:lnSpc>
-                <a:spcPct val="110000"/>
-              </a:lnSpc>
-              <a:spcBef>
-                <a:spcPts val="0"/>
-              </a:spcBef>
-              <a:spcAft>
-                <a:spcPts val="0"/>
-              </a:spcAft>
-            </a:pPr>
-            <a:r>
-              <a:rPr sz="750" b="1" i="0">
-                <a:solidFill>
-                  <a:srgbClr val="8A94A3"/>
-                </a:solidFill>
-                <a:latin typeface="Consolas"/>
-                <a:ea typeface="Consolas"/>
-                <a:cs typeface="Consolas"/>
-              </a:rPr>
-              <a:t>3</a:t>
-            </a:r>
-          </a:p>
-        </p:txBody>
-      </p:sp>
-      <p:cxnSp>
-        <p:nvCxnSpPr>
-          <p:cNvPr id="29" name="Connector 28"/>
-          <p:cNvCxnSpPr/>
-          <p:nvPr/>
-        </p:nvCxnSpPr>
-        <p:spPr>
-          <a:xfrm>
-            <a:off x="6903720" y="3127248"/>
-            <a:ext cx="4087368" cy="1371600"/>
-          </a:xfrm>
-          <a:prstGeom prst="line">
-            <a:avLst/>
-          </a:prstGeom>
-          <a:ln w="11430">
-            <a:solidFill>
-              <a:srgbClr val="D8C2C2"/>
-            </a:solidFill>
-          </a:ln>
-        </p:spPr>
-        <p:style>
-          <a:lnRef idx="2">
-            <a:schemeClr val="accent1"/>
-          </a:lnRef>
-          <a:fillRef idx="0">
-            <a:schemeClr val="accent1"/>
-          </a:fillRef>
-          <a:effectRef idx="1">
-            <a:schemeClr val="accent1"/>
-          </a:effectRef>
-          <a:fontRef idx="minor">
-            <a:schemeClr val="tx1"/>
-          </a:fontRef>
-        </p:style>
-      </p:cxnSp>
-      <p:sp>
-        <p:nvSpPr>
-          <p:cNvPr id="30" name="TextBox 29"/>
-          <p:cNvSpPr txBox="1"/>
-          <p:nvPr/>
-        </p:nvSpPr>
-        <p:spPr>
-          <a:xfrm>
-            <a:off x="6565392" y="3364991"/>
-            <a:ext cx="329184" cy="201168"/>
-          </a:xfrm>
-          <a:prstGeom prst="rect">
-            <a:avLst/>
-          </a:prstGeom>
-          <a:noFill/>
-        </p:spPr>
-        <p:txBody>
-          <a:bodyPr wrap="square" lIns="0" tIns="0" rIns="0" bIns="0" anchor="t">
-            <a:noAutofit/>
-          </a:bodyPr>
-          <a:lstStyle/>
-          <a:p>
-            <a:pPr algn="l">
-              <a:lnSpc>
-                <a:spcPct val="110000"/>
-              </a:lnSpc>
-              <a:spcBef>
-                <a:spcPts val="0"/>
-              </a:spcBef>
-              <a:spcAft>
-                <a:spcPts val="0"/>
-              </a:spcAft>
-            </a:pPr>
-            <a:r>
-              <a:rPr sz="750" b="1" i="0">
-                <a:solidFill>
-                  <a:srgbClr val="8A94A3"/>
-                </a:solidFill>
-                <a:latin typeface="Consolas"/>
-                <a:ea typeface="Consolas"/>
-                <a:cs typeface="Consolas"/>
-              </a:rPr>
-              <a:t>4</a:t>
-            </a:r>
-          </a:p>
-        </p:txBody>
-      </p:sp>
-      <p:cxnSp>
-        <p:nvCxnSpPr>
-          <p:cNvPr id="31" name="Connector 30"/>
-          <p:cNvCxnSpPr/>
-          <p:nvPr/>
-        </p:nvCxnSpPr>
-        <p:spPr>
-          <a:xfrm>
-            <a:off x="6903720" y="3456432"/>
-            <a:ext cx="4087368" cy="1042416"/>
-          </a:xfrm>
-          <a:prstGeom prst="line">
-            <a:avLst/>
-          </a:prstGeom>
-          <a:ln w="11430">
-            <a:solidFill>
-              <a:srgbClr val="D8C2C2"/>
-            </a:solidFill>
-          </a:ln>
-        </p:spPr>
-        <p:style>
-          <a:lnRef idx="2">
-            <a:schemeClr val="accent1"/>
-          </a:lnRef>
-          <a:fillRef idx="0">
-            <a:schemeClr val="accent1"/>
-          </a:fillRef>
-          <a:effectRef idx="1">
-            <a:schemeClr val="accent1"/>
-          </a:effectRef>
-          <a:fontRef idx="minor">
-            <a:schemeClr val="tx1"/>
-          </a:fontRef>
-        </p:style>
-      </p:cxnSp>
-      <p:sp>
-        <p:nvSpPr>
-          <p:cNvPr id="32" name="TextBox 31"/>
-          <p:cNvSpPr txBox="1"/>
-          <p:nvPr/>
-        </p:nvSpPr>
-        <p:spPr>
-          <a:xfrm>
-            <a:off x="6565392" y="3694176"/>
-            <a:ext cx="329184" cy="201168"/>
-          </a:xfrm>
-          <a:prstGeom prst="rect">
-            <a:avLst/>
-          </a:prstGeom>
-          <a:noFill/>
-        </p:spPr>
-        <p:txBody>
-          <a:bodyPr wrap="square" lIns="0" tIns="0" rIns="0" bIns="0" anchor="t">
-            <a:noAutofit/>
-          </a:bodyPr>
-          <a:lstStyle/>
-          <a:p>
-            <a:pPr algn="l">
-              <a:lnSpc>
-                <a:spcPct val="110000"/>
-              </a:lnSpc>
-              <a:spcBef>
-                <a:spcPts val="0"/>
-              </a:spcBef>
-              <a:spcAft>
-                <a:spcPts val="0"/>
-              </a:spcAft>
-            </a:pPr>
-            <a:r>
-              <a:rPr sz="750" b="1" i="0">
-                <a:solidFill>
-                  <a:srgbClr val="8A94A3"/>
-                </a:solidFill>
-                <a:latin typeface="Consolas"/>
-                <a:ea typeface="Consolas"/>
-                <a:cs typeface="Consolas"/>
-              </a:rPr>
-              <a:t>5</a:t>
-            </a:r>
-          </a:p>
-        </p:txBody>
-      </p:sp>
-      <p:cxnSp>
-        <p:nvCxnSpPr>
-          <p:cNvPr id="33" name="Connector 32"/>
-          <p:cNvCxnSpPr/>
-          <p:nvPr/>
-        </p:nvCxnSpPr>
-        <p:spPr>
-          <a:xfrm>
-            <a:off x="6903720" y="3785615"/>
-            <a:ext cx="4087368" cy="713233"/>
-          </a:xfrm>
-          <a:prstGeom prst="line">
-            <a:avLst/>
-          </a:prstGeom>
-          <a:ln w="11430">
-            <a:solidFill>
-              <a:srgbClr val="D8C2C2"/>
-            </a:solidFill>
-          </a:ln>
-        </p:spPr>
-        <p:style>
-          <a:lnRef idx="2">
-            <a:schemeClr val="accent1"/>
-          </a:lnRef>
-          <a:fillRef idx="0">
-            <a:schemeClr val="accent1"/>
-          </a:fillRef>
-          <a:effectRef idx="1">
-            <a:schemeClr val="accent1"/>
-          </a:effectRef>
-          <a:fontRef idx="minor">
-            <a:schemeClr val="tx1"/>
-          </a:fontRef>
-        </p:style>
-      </p:cxnSp>
-      <p:sp>
-        <p:nvSpPr>
-          <p:cNvPr id="34" name="TextBox 33"/>
-          <p:cNvSpPr txBox="1"/>
-          <p:nvPr/>
-        </p:nvSpPr>
-        <p:spPr>
-          <a:xfrm>
-            <a:off x="6565392" y="4023360"/>
-            <a:ext cx="329184" cy="201168"/>
-          </a:xfrm>
-          <a:prstGeom prst="rect">
-            <a:avLst/>
-          </a:prstGeom>
-          <a:noFill/>
-        </p:spPr>
-        <p:txBody>
-          <a:bodyPr wrap="square" lIns="0" tIns="0" rIns="0" bIns="0" anchor="t">
-            <a:noAutofit/>
-          </a:bodyPr>
-          <a:lstStyle/>
-          <a:p>
-            <a:pPr algn="l">
-              <a:lnSpc>
-                <a:spcPct val="110000"/>
-              </a:lnSpc>
-              <a:spcBef>
-                <a:spcPts val="0"/>
-              </a:spcBef>
-              <a:spcAft>
-                <a:spcPts val="0"/>
-              </a:spcAft>
-            </a:pPr>
-            <a:r>
-              <a:rPr sz="750" b="1" i="0">
-                <a:solidFill>
-                  <a:srgbClr val="8A94A3"/>
-                </a:solidFill>
-                <a:latin typeface="Consolas"/>
-                <a:ea typeface="Consolas"/>
-                <a:cs typeface="Consolas"/>
-              </a:rPr>
-              <a:t>6</a:t>
-            </a:r>
-          </a:p>
-        </p:txBody>
-      </p:sp>
-      <p:cxnSp>
-        <p:nvCxnSpPr>
-          <p:cNvPr id="35" name="Connector 34"/>
-          <p:cNvCxnSpPr/>
-          <p:nvPr/>
-        </p:nvCxnSpPr>
-        <p:spPr>
-          <a:xfrm>
-            <a:off x="6903720" y="4114800"/>
-            <a:ext cx="4087368" cy="384048"/>
-          </a:xfrm>
-          <a:prstGeom prst="line">
-            <a:avLst/>
-          </a:prstGeom>
-          <a:ln w="11430">
-            <a:solidFill>
-              <a:srgbClr val="D8C2C2"/>
-            </a:solidFill>
-          </a:ln>
-        </p:spPr>
-        <p:style>
-          <a:lnRef idx="2">
-            <a:schemeClr val="accent1"/>
-          </a:lnRef>
-          <a:fillRef idx="0">
-            <a:schemeClr val="accent1"/>
-          </a:fillRef>
-          <a:effectRef idx="1">
-            <a:schemeClr val="accent1"/>
-          </a:effectRef>
-          <a:fontRef idx="minor">
-            <a:schemeClr val="tx1"/>
-          </a:fontRef>
-        </p:style>
-      </p:cxnSp>
-      <p:sp>
-        <p:nvSpPr>
-          <p:cNvPr id="36" name="Rectangle 35"/>
+        <p:txBody>
+          <a:bodyPr rtlCol="0" anchor="ctr"/>
+          <a:lstStyle/>
+          <a:p>
+            <a:pPr algn="ctr"/>
+          </a:p>
+        </p:txBody>
+      </p:sp>
+      <p:sp>
+        <p:nvSpPr>
+          <p:cNvPr id="25" name="Rectangle 24"/>
           <p:cNvSpPr/>
           <p:nvPr/>
         </p:nvSpPr>
         <p:spPr>
           <a:xfrm>
-            <a:off x="11082528" y="2834640"/>
-            <a:ext cx="45720" cy="1920240"/>
+            <a:off x="8321040" y="2907792"/>
+            <a:ext cx="54864" cy="1188720"/>
           </a:xfrm>
           <a:prstGeom prst="rect">
             <a:avLst/>
@@ -21136,24 +20690,23 @@
           </a:fontRef>
         </p:style>
         <p:txBody>
-          <a:bodyPr wrap="square" lIns="0" tIns="0" rIns="0" bIns="0" rtlCol="0" anchor="ctr"/>
+          <a:bodyPr rtlCol="0" anchor="ctr"/>
           <a:lstStyle/>
           <a:p>
             <a:pPr algn="ctr"/>
-            <a:endParaRPr/>
-          </a:p>
-        </p:txBody>
-      </p:sp>
-      <p:sp>
-        <p:nvSpPr>
-          <p:cNvPr id="37" name="TextBox 36"/>
+          </a:p>
+        </p:txBody>
+      </p:sp>
+      <p:sp>
+        <p:nvSpPr>
+          <p:cNvPr id="26" name="TextBox 25"/>
           <p:cNvSpPr txBox="1"/>
           <p:nvPr/>
         </p:nvSpPr>
         <p:spPr>
           <a:xfrm>
-            <a:off x="11228832" y="3182112"/>
-            <a:ext cx="822960" cy="1463040"/>
+            <a:off x="8540496" y="3054096"/>
+            <a:ext cx="3017520" cy="310896"/>
           </a:xfrm>
           <a:prstGeom prst="rect">
             <a:avLst/>
@@ -21161,60 +20714,254 @@
           <a:noFill/>
         </p:spPr>
         <p:txBody>
-          <a:bodyPr wrap="square" lIns="0" tIns="0" rIns="0" bIns="0" anchor="t">
-            <a:noAutofit/>
-          </a:bodyPr>
-          <a:lstStyle/>
-          <a:p>
-            <a:pPr algn="ctr">
-              <a:lnSpc>
-                <a:spcPct val="125000"/>
-              </a:lnSpc>
-              <a:spcBef>
-                <a:spcPts val="0"/>
-              </a:spcBef>
-              <a:spcAft>
-                <a:spcPts val="0"/>
-              </a:spcAft>
-            </a:pPr>
-            <a:r>
-              <a:rPr sz="850" b="1" i="0">
+          <a:bodyPr wrap="square" lIns="0" rIns="0" tIns="0" bIns="0">
+            <a:spAutoFit/>
+          </a:bodyPr>
+          <a:lstStyle/>
+          <a:p>
+            <a:r>
+              <a:rPr sz="1500" b="1">
+                <a:solidFill>
+                  <a:srgbClr val="1F2328"/>
+                </a:solidFill>
+                <a:latin typeface="微软雅黑"/>
+              </a:rPr>
+              <a:t>Ascend 适配层</a:t>
+            </a:r>
+          </a:p>
+        </p:txBody>
+      </p:sp>
+      <p:sp>
+        <p:nvSpPr>
+          <p:cNvPr id="27" name="TextBox 26"/>
+          <p:cNvSpPr txBox="1"/>
+          <p:nvPr/>
+        </p:nvSpPr>
+        <p:spPr>
+          <a:xfrm>
+            <a:off x="8540496" y="3401568"/>
+            <a:ext cx="3017520" cy="256032"/>
+          </a:xfrm>
+          <a:prstGeom prst="rect">
+            <a:avLst/>
+          </a:prstGeom>
+          <a:noFill/>
+        </p:spPr>
+        <p:txBody>
+          <a:bodyPr wrap="square" lIns="0" rIns="0" tIns="0" bIns="0">
+            <a:spAutoFit/>
+          </a:bodyPr>
+          <a:lstStyle/>
+          <a:p>
+            <a:r>
+              <a:rPr sz="1000">
                 <a:solidFill>
                   <a:srgbClr val="5A6472"/>
                 </a:solidFill>
                 <a:latin typeface="微软雅黑"/>
-                <a:ea typeface="微软雅黑"/>
-                <a:cs typeface="微软雅黑"/>
-              </a:rPr>
-              <a:t>通用 vLLM</a:t>
-            </a:r>
-            <a:r>
-              <a:rPr sz="800" b="0" i="0">
-                <a:solidFill>
-                  <a:srgbClr val="8A94A3"/>
+              </a:rPr>
+              <a:t>vllm-ascend  ·  插件 + patch</a:t>
+            </a:r>
+          </a:p>
+        </p:txBody>
+      </p:sp>
+      <p:sp>
+        <p:nvSpPr>
+          <p:cNvPr id="28" name="Rectangle 27"/>
+          <p:cNvSpPr/>
+          <p:nvPr/>
+        </p:nvSpPr>
+        <p:spPr>
+          <a:xfrm>
+            <a:off x="8321040" y="4315968"/>
+            <a:ext cx="3364992" cy="566928"/>
+          </a:xfrm>
+          <a:prstGeom prst="rect">
+            <a:avLst/>
+          </a:prstGeom>
+          <a:solidFill>
+            <a:srgbClr val="E9EBED"/>
+          </a:solidFill>
+          <a:ln w="12700">
+            <a:solidFill>
+              <a:srgbClr val="DCE1E7"/>
+            </a:solidFill>
+          </a:ln>
+          <a:effectLst/>
+        </p:spPr>
+        <p:style>
+          <a:lnRef idx="1">
+            <a:schemeClr val="accent1"/>
+          </a:lnRef>
+          <a:fillRef idx="3">
+            <a:schemeClr val="accent1"/>
+          </a:fillRef>
+          <a:effectRef idx="2">
+            <a:schemeClr val="accent1"/>
+          </a:effectRef>
+          <a:fontRef idx="minor">
+            <a:schemeClr val="lt1"/>
+          </a:fontRef>
+        </p:style>
+        <p:txBody>
+          <a:bodyPr rtlCol="0" anchor="ctr"/>
+          <a:lstStyle/>
+          <a:p>
+            <a:pPr algn="ctr"/>
+          </a:p>
+        </p:txBody>
+      </p:sp>
+      <p:sp>
+        <p:nvSpPr>
+          <p:cNvPr id="29" name="TextBox 28"/>
+          <p:cNvSpPr txBox="1"/>
+          <p:nvPr/>
+        </p:nvSpPr>
+        <p:spPr>
+          <a:xfrm>
+            <a:off x="8540496" y="4462272"/>
+            <a:ext cx="3017520" cy="274320"/>
+          </a:xfrm>
+          <a:prstGeom prst="rect">
+            <a:avLst/>
+          </a:prstGeom>
+          <a:noFill/>
+        </p:spPr>
+        <p:txBody>
+          <a:bodyPr wrap="square" lIns="0" rIns="0" tIns="0" bIns="0">
+            <a:spAutoFit/>
+          </a:bodyPr>
+          <a:lstStyle/>
+          <a:p>
+            <a:r>
+              <a:rPr sz="1200" b="1">
+                <a:solidFill>
+                  <a:srgbClr val="1F2328"/>
                 </a:solidFill>
                 <a:latin typeface="微软雅黑"/>
-                <a:ea typeface="微软雅黑"/>
-                <a:cs typeface="微软雅黑"/>
-              </a:rPr>
-              <a:t>
-+
-</a:t>
-            </a:r>
-            <a:r>
-              <a:rPr sz="850" b="1" i="0">
-                <a:solidFill>
-                  <a:srgbClr val="C00000"/>
+              </a:rPr>
+              <a:t>vLLM 主仓  0.30.0</a:t>
+            </a:r>
+            <a:r>
+              <a:rPr sz="1000">
+                <a:solidFill>
+                  <a:srgbClr val="5A6472"/>
                 </a:solidFill>
                 <a:latin typeface="微软雅黑"/>
-                <a:ea typeface="微软雅黑"/>
-                <a:cs typeface="微软雅黑"/>
-              </a:rPr>
-              <a:t>一层适配</a:t>
-            </a:r>
-          </a:p>
-        </p:txBody>
-      </p:sp>
+              </a:rPr>
+              <a:t>   一行不改</a:t>
+            </a:r>
+          </a:p>
+        </p:txBody>
+      </p:sp>
+      <p:cxnSp>
+        <p:nvCxnSpPr>
+          <p:cNvPr id="30" name="Connector 29"/>
+          <p:cNvCxnSpPr/>
+          <p:nvPr/>
+        </p:nvCxnSpPr>
+        <p:spPr>
+          <a:xfrm>
+            <a:off x="10003536" y="4096512"/>
+            <a:ext cx="0" cy="219456"/>
+          </a:xfrm>
+          <a:prstGeom prst="line">
+            <a:avLst/>
+          </a:prstGeom>
+          <a:ln w="19050">
+            <a:solidFill>
+              <a:srgbClr val="5A6472"/>
+            </a:solidFill>
+            <a:tailEnd type="triangle" w="med" len="med"/>
+          </a:ln>
+        </p:spPr>
+        <p:style>
+          <a:lnRef idx="2">
+            <a:schemeClr val="accent1"/>
+          </a:lnRef>
+          <a:fillRef idx="0">
+            <a:schemeClr val="accent1"/>
+          </a:fillRef>
+          <a:effectRef idx="1">
+            <a:schemeClr val="accent1"/>
+          </a:effectRef>
+          <a:fontRef idx="minor">
+            <a:schemeClr val="tx1"/>
+          </a:fontRef>
+        </p:style>
+      </p:cxnSp>
+      <p:cxnSp>
+        <p:nvCxnSpPr>
+          <p:cNvPr id="31" name="Connector 30"/>
+          <p:cNvCxnSpPr/>
+          <p:nvPr/>
+        </p:nvCxnSpPr>
+        <p:spPr>
+          <a:xfrm>
+            <a:off x="6236208" y="2889504"/>
+            <a:ext cx="2048256" cy="548640"/>
+          </a:xfrm>
+          <a:prstGeom prst="line">
+            <a:avLst/>
+          </a:prstGeom>
+          <a:ln w="25400">
+            <a:solidFill>
+              <a:srgbClr val="C00000"/>
+            </a:solidFill>
+            <a:tailEnd type="triangle" w="med" len="med"/>
+          </a:ln>
+        </p:spPr>
+        <p:style>
+          <a:lnRef idx="2">
+            <a:schemeClr val="accent1"/>
+          </a:lnRef>
+          <a:fillRef idx="0">
+            <a:schemeClr val="accent1"/>
+          </a:fillRef>
+          <a:effectRef idx="1">
+            <a:schemeClr val="accent1"/>
+          </a:effectRef>
+          <a:fontRef idx="minor">
+            <a:schemeClr val="tx1"/>
+          </a:fontRef>
+        </p:style>
+      </p:cxnSp>
+      <p:cxnSp>
+        <p:nvCxnSpPr>
+          <p:cNvPr id="32" name="Connector 31"/>
+          <p:cNvCxnSpPr/>
+          <p:nvPr/>
+        </p:nvCxnSpPr>
+        <p:spPr>
+          <a:xfrm flipV="1">
+            <a:off x="6236208" y="3584448"/>
+            <a:ext cx="2048256" cy="566928"/>
+          </a:xfrm>
+          <a:prstGeom prst="line">
+            <a:avLst/>
+          </a:prstGeom>
+          <a:ln w="25400">
+            <a:solidFill>
+              <a:srgbClr val="0E7C8A"/>
+            </a:solidFill>
+            <a:tailEnd type="triangle" w="med" len="med"/>
+          </a:ln>
+        </p:spPr>
+        <p:style>
+          <a:lnRef idx="2">
+            <a:schemeClr val="accent1"/>
+          </a:lnRef>
+          <a:fillRef idx="0">
+            <a:schemeClr val="accent1"/>
+          </a:fillRef>
+          <a:effectRef idx="1">
+            <a:schemeClr val="accent1"/>
+          </a:effectRef>
+          <a:fontRef idx="minor">
+            <a:schemeClr val="tx1"/>
+          </a:fontRef>
+        </p:style>
+      </p:cxnSp>
     </p:spTree>
   </p:cSld>
   <p:clrMapOvr>

</xml_diff>